<commit_message>
Strip third-party project data from the artifact templates
presentation-template.pptx shipped as a completed deck for a real project
(21 of 34 slides), including its unit economics, burn rate, runway, funding
need, persona and competitor teardown. Those slides carried no placeholders, so
the documented quality gate could not catch them. Every one is now a
placeholder; the deck keeps its 34 slides and layout.

financial-plan-template.xlsx carried a real weekly sales log naming U2Y,
SMARTC, Bitrace, BLESK and AldanDev, apparel-specific segment labels, a named
bank integration, and a personal name in the document metadata.

Co-Authored-By: Claude Opus 5 <noreply@anthropic.com>
Claude-Session: https://claude.ai/code/session_01VBUBx5WdGh1wxMo66Mt7Zn
</commit_message>
<xml_diff>
--- a/assets/presentation-template.pptx
+++ b/assets/presentation-template.pptx
@@ -599,7 +599,7 @@
                 <a:latin typeface="Calibri"/>
                 <a:ea typeface="Calibri"/>
               </a:rPr>
-              <a:t>WONDER DIAMOND</a:t>
+              <a:t>[НАЗВАНИЕ ПРОЕКТА]</a:t>
             </a:r>
             <a:endParaRPr b="0" lang="en-US" sz="3800" spc="-1" strike="noStrike">
               <a:solidFill>
@@ -656,7 +656,7 @@
                 <a:latin typeface="Calibri"/>
                 <a:ea typeface="Calibri"/>
               </a:rPr>
-              <a:t>CVD-бриллиантовые украшения 6ct+ от производителя — в 10–50× дешевле натуральных</a:t>
+              <a:t>[Краткий слоган: суть продукта в одном предложении]</a:t>
             </a:r>
             <a:endParaRPr b="0" lang="en-US" sz="1500" spc="-1" strike="noStrike">
               <a:solidFill>
@@ -713,7 +713,7 @@
                 <a:latin typeface="Calibri"/>
                 <a:ea typeface="Calibri"/>
               </a:rPr>
-              <a:t>Россия, B2C  ·  Апрель 2026  ·  Этап: Verification</a:t>
+              <a:t>[Рынок], [B2B / B2C]  ·  [месяц год]  ·  Этап: Verification</a:t>
             </a:r>
             <a:endParaRPr b="0" lang="en-US" sz="900" spc="-1" strike="noStrike">
               <a:solidFill>
@@ -1019,7 +1019,7 @@
                 <a:latin typeface="Calibri"/>
                 <a:ea typeface="Calibri"/>
               </a:rPr>
-              <a:t>Источник: probpalata.gov.ru, Минфин РФ, Ассоциация ювелиров РФ 2025–2026</a:t>
+              <a:t>Источник: [регуляторы, отраслевые ассоциации, статистика — задача 6]</a:t>
             </a:r>
             <a:endParaRPr b="0" lang="en-US" sz="800" spc="-1" strike="noStrike">
               <a:solidFill>
@@ -1182,7 +1182,7 @@
                 <a:latin typeface="Calibri"/>
                 <a:ea typeface="Calibri"/>
               </a:rPr>
-              <a:t>POLITICAL: Закон 334-ФЗ (ГИИС ДМДК с 01.03.2026): 3×5=15 ⚠️ Compliance обязателен. Санкции → усложнение импорта: 2×3=6</a:t>
+              <a:t>POLITICAL: [фактор]: [значимость]×[вероятность]=[оценка] [⚠️ / ✅] [следствие]</a:t>
             </a:r>
             <a:endParaRPr b="0" lang="en-US" sz="950" spc="-1" strike="noStrike">
               <a:solidFill>
@@ -1345,7 +1345,7 @@
                 <a:latin typeface="Calibri"/>
                 <a:ea typeface="Calibri"/>
               </a:rPr>
-              <a:t>ECONOMIC: Рост цены золота +45% (2024): 3×4=12 ⚠️ Рост COGS. Высокая ставка ЦБ: 2×4=8. Рост ювелирки +17%: 2×4=8 ✅</a:t>
+              <a:t>ECONOMIC: [фактор]: [значимость]×[вероятность]=[оценка] [⚠️ / ✅] [следствие]</a:t>
             </a:r>
             <a:endParaRPr b="0" lang="en-US" sz="950" spc="-1" strike="noStrike">
               <a:solidFill>
@@ -1508,7 +1508,7 @@
                 <a:latin typeface="Calibri"/>
                 <a:ea typeface="Calibri"/>
               </a:rPr>
-              <a:t>SOCIAL: Премиализация, доля украшений с камнями 45–50%: 3×4=12 ✅ спрос растёт. Стигма «синтетика» у 45+: 3×3=9 ⚠️ ограничивает TAM. ESG-тренд: 2×3=6 ✅</a:t>
+              <a:t>SOCIAL: [фактор]: [значимость]×[вероятность]=[оценка] [⚠️ / ✅] [следствие]</a:t>
             </a:r>
             <a:endParaRPr b="0" lang="en-US" sz="950" spc="-1" strike="noStrike">
               <a:solidFill>
@@ -1671,7 +1671,7 @@
                 <a:latin typeface="Calibri"/>
                 <a:ea typeface="Calibri"/>
               </a:rPr>
-              <a:t>TECHNOLOGICAL: CVD дешевеет, рост маржи: 2×5=10 ✅. AR-примерка как UX-барьер: 1×3=3 ✅ дифференциация</a:t>
+              <a:t>TECHNOLOGICAL: [фактор]: [значимость]×[вероятность]=[оценка] [⚠️ / ✅] [следствие]</a:t>
             </a:r>
             <a:endParaRPr b="0" lang="en-US" sz="950" spc="-1" strike="noStrike">
               <a:solidFill>
@@ -1834,7 +1834,7 @@
                 <a:latin typeface="Calibri"/>
                 <a:ea typeface="Calibri"/>
               </a:rPr>
-              <a:t>LEGAL: 2D-маркировка с сент. 2025: 2×5=10 ⚠️ операционный риск. ГИИС ДМДК compliance: 3×5=15 — критично проверить до первых продаж</a:t>
+              <a:t>ENVIRONMENTAL / LEGAL: [фактор]: [значимость]×[вероятность]=[оценка] [⚠️ / ✅] [следствие]</a:t>
             </a:r>
             <a:endParaRPr b="0" lang="en-US" sz="950" spc="-1" strike="noStrike">
               <a:solidFill>
@@ -2340,7 +2340,7 @@
                 <a:latin typeface="Calibri"/>
                 <a:ea typeface="Calibri"/>
               </a:rPr>
-              <a:t>Источник: Jobs-to-be-Done (Ulwick/Christensen); PD WD 2026</a:t>
+              <a:t>Источник: Jobs-to-be-Done (Ulwick/Christensen); задача 7</a:t>
             </a:r>
             <a:endParaRPr b="0" lang="en-US" sz="800" spc="-1" strike="noStrike">
               <a:solidFill>
@@ -2618,7 +2618,7 @@
                 <a:latin typeface="Calibri"/>
                 <a:ea typeface="Calibri"/>
               </a:rPr>
-              <a:t>Купить ювелирное украшение с крупным бриллиантом; выбрать из ассортимента подходящее; получить доставку на 200K+ ₽</a:t>
+              <a:t>[Функциональные работы: что клиент делает практически — 2–3 формулировки]</a:t>
             </a:r>
             <a:endParaRPr b="0" lang="en-US" sz="950" spc="-1" strike="noStrike">
               <a:solidFill>
@@ -2839,7 +2839,7 @@
                 <a:latin typeface="Calibri"/>
                 <a:ea typeface="Calibri"/>
               </a:rPr>
-              <a:t>Уверенность в покупке; гордость за качество; ощущение роскоши без финансового напряжения</a:t>
+              <a:t>[Эмоциональные работы: что клиент хочет чувствовать]</a:t>
             </a:r>
             <a:endParaRPr b="0" lang="en-US" sz="950" spc="-1" strike="noStrike">
               <a:solidFill>
@@ -3060,7 +3060,7 @@
                 <a:latin typeface="Calibri"/>
                 <a:ea typeface="Calibri"/>
               </a:rPr>
-              <a:t>Статусной, успешной; человеком со вкусом; «при деньгах» без показного расточительства</a:t>
+              <a:t>[Социальные работы: как клиент хочет выглядеть в глазах других]</a:t>
             </a:r>
             <a:endParaRPr b="0" lang="en-US" sz="950" spc="-1" strike="noStrike">
               <a:solidFill>
@@ -3272,7 +3272,7 @@
                 <a:latin typeface="Calibri"/>
                 <a:ea typeface="Calibri"/>
               </a:rPr>
-              <a:t>Когда я хочу украшение с крупным бриллиантом, я хочу найти доступный вариант 6ct+, чтобы выглядеть статусно без затрат 1–5 млн ₽.</a:t>
+              <a:t>Когда [ситуация], я хочу [работа], чтобы [результат].</a:t>
             </a:r>
             <a:endParaRPr b="0" lang="en-US" sz="1000" spc="-1" strike="noStrike">
               <a:solidFill>
@@ -3427,7 +3427,7 @@
                 <a:latin typeface="Calibri"/>
                 <a:ea typeface="Calibri"/>
               </a:rPr>
-              <a:t>Когда я выбираю подарок на юбилей, я хочу вложиться в украшение с эффектом, чтобы запомниться без бюджета ювелирного бутика.</a:t>
+              <a:t>Когда [ситуация], я хочу [работа], чтобы [результат].</a:t>
             </a:r>
             <a:endParaRPr b="0" lang="en-US" sz="1000" spc="-1" strike="noStrike">
               <a:solidFill>
@@ -3582,7 +3582,7 @@
                 <a:latin typeface="Calibri"/>
                 <a:ea typeface="Calibri"/>
               </a:rPr>
-              <a:t>Когда я узнаю про CVD, я хочу убедиться в подлинности через IGI-сертификат, чтобы не выглядеть глупо перед окружением.</a:t>
+              <a:t>Когда [ситуация], я хочу [работа], чтобы [результат].</a:t>
             </a:r>
             <a:endParaRPr b="0" lang="en-US" sz="1000" spc="-1" strike="noStrike">
               <a:solidFill>
@@ -8385,7 +8385,7 @@
                 <a:latin typeface="Calibri"/>
                 <a:ea typeface="Calibri"/>
               </a:rPr>
-              <a:t>Источник: Суррогатные данные — отзывы IQ Diamonds, Bright Spark, Ozon; форумы VC.ru; PD WD 2026</a:t>
+              <a:t>Источник: [интервью или суррогатные данные — отзывы, форумы; задача 9]</a:t>
             </a:r>
             <a:endParaRPr b="0" lang="en-US" sz="800" spc="-1" strike="noStrike">
               <a:solidFill>
@@ -8548,7 +8548,7 @@
                 <a:latin typeface="Calibri"/>
                 <a:ea typeface="Calibri"/>
               </a:rPr>
-              <a:t>5/7</a:t>
+              <a:t>[N/M]</a:t>
             </a:r>
             <a:endParaRPr b="0" lang="en-US" sz="1300" spc="-1" strike="noStrike">
               <a:solidFill>
@@ -8711,7 +8711,7 @@
                 <a:latin typeface="Calibri"/>
                 <a:ea typeface="Calibri"/>
               </a:rPr>
-              <a:t>Ищут крупный камень (5ct+), но в каталогах РФ не находят — уходят или ждут</a:t>
+              <a:t>[Паттерн 1: что респонденты делают или чувствуют]</a:t>
             </a:r>
             <a:endParaRPr b="0" lang="en-US" sz="1000" spc="-1" strike="noStrike">
               <a:solidFill>
@@ -8817,7 +8817,7 @@
                 <a:latin typeface="Calibri"/>
                 <a:ea typeface="Calibri"/>
               </a:rPr>
-              <a:t>7/7</a:t>
+              <a:t>[N/M]</a:t>
             </a:r>
             <a:endParaRPr b="0" lang="en-US" sz="1300" spc="-1" strike="noStrike">
               <a:solidFill>
@@ -8980,7 +8980,7 @@
                 <a:latin typeface="Calibri"/>
                 <a:ea typeface="Calibri"/>
               </a:rPr>
-              <a:t>Убедиться в подлинности — барьер #1: требуют IGI/GIA, фото сертификата</a:t>
+              <a:t>[Паттерн 2: что респонденты делают или чувствуют]</a:t>
             </a:r>
             <a:endParaRPr b="0" lang="en-US" sz="1000" spc="-1" strike="noStrike">
               <a:solidFill>
@@ -9086,7 +9086,7 @@
                 <a:latin typeface="Calibri"/>
                 <a:ea typeface="Calibri"/>
               </a:rPr>
-              <a:t>6/7</a:t>
+              <a:t>[N/M]</a:t>
             </a:r>
             <a:endParaRPr b="0" lang="en-US" sz="1300" spc="-1" strike="noStrike">
               <a:solidFill>
@@ -9249,7 +9249,7 @@
                 <a:latin typeface="Calibri"/>
                 <a:ea typeface="Calibri"/>
               </a:rPr>
-              <a:t>Нет уверенности покупать 200K+ онлайн без физической примерки</a:t>
+              <a:t>[Паттерн 3: что респонденты делают или чувствуют]</a:t>
             </a:r>
             <a:endParaRPr b="0" lang="en-US" sz="1000" spc="-1" strike="noStrike">
               <a:solidFill>
@@ -9355,7 +9355,7 @@
                 <a:latin typeface="Calibri"/>
                 <a:ea typeface="Calibri"/>
               </a:rPr>
-              <a:t>4/7</a:t>
+              <a:t>[N/M]</a:t>
             </a:r>
             <a:endParaRPr b="0" lang="en-US" sz="1300" spc="-1" strike="noStrike">
               <a:solidFill>
@@ -9518,7 +9518,7 @@
                 <a:latin typeface="Calibri"/>
                 <a:ea typeface="Calibri"/>
               </a:rPr>
-              <a:t>Премиум-покупатели готовы платить за upgrade — «а если камень мне разонравится, можно поменять?»</a:t>
+              <a:t>[Паттерн 4: что респонденты делают или чувствуют]</a:t>
             </a:r>
             <a:endParaRPr b="0" lang="en-US" sz="1000" spc="-1" strike="noStrike">
               <a:solidFill>
@@ -9624,7 +9624,7 @@
                 <a:latin typeface="Calibri"/>
                 <a:ea typeface="Calibri"/>
               </a:rPr>
-              <a:t>3/7</a:t>
+              <a:t>[N/M]</a:t>
             </a:r>
             <a:endParaRPr b="0" lang="en-US" sz="1300" spc="-1" strike="noStrike">
               <a:solidFill>
@@ -9787,7 +9787,7 @@
                 <a:latin typeface="Calibri"/>
                 <a:ea typeface="Calibri"/>
               </a:rPr>
-              <a:t>Социальное давление на сегмент 40+: «а это точно настоящий бриллиант?» от окружения</a:t>
+              <a:t>[Паттерн 5: что респонденты делают или чувствуют]</a:t>
             </a:r>
             <a:endParaRPr b="0" lang="en-US" sz="1000" spc="-1" strike="noStrike">
               <a:solidFill>
@@ -10093,7 +10093,7 @@
                 <a:latin typeface="Calibri"/>
                 <a:ea typeface="Calibri"/>
               </a:rPr>
-              <a:t>Источник: Opportunity Score (Ulwick); PD WD 2026</a:t>
+              <a:t>Источник: Opportunity Score (Ulwick); задачи 7, 17</a:t>
             </a:r>
             <a:endParaRPr b="0" lang="en-US" sz="800" spc="-1" strike="noStrike">
               <a:solidFill>
@@ -10786,7 +10786,7 @@
                 <a:latin typeface="Calibri"/>
                 <a:ea typeface="Calibri"/>
               </a:rPr>
-              <a:t>Доступный крупный CVD-бриллиант (6ct+)</a:t>
+              <a:t>[Outcome 1 из Job Map]</a:t>
             </a:r>
             <a:endParaRPr b="0" lang="en-US" sz="950" spc="-1" strike="noStrike">
               <a:solidFill>
@@ -11326,7 +11326,7 @@
                 <a:latin typeface="Calibri"/>
                 <a:ea typeface="Calibri"/>
               </a:rPr>
-              <a:t>Уверенность в подлинности (IGI-сертификат)</a:t>
+              <a:t>[Outcome 2 из Job Map]</a:t>
             </a:r>
             <a:endParaRPr b="0" lang="en-US" sz="950" spc="-1" strike="noStrike">
               <a:solidFill>
@@ -11866,7 +11866,7 @@
                 <a:latin typeface="Calibri"/>
                 <a:ea typeface="Calibri"/>
               </a:rPr>
-              <a:t>Украшение «смотрится дорого» — социальный сигнал</a:t>
+              <a:t>[Outcome 3 из Job Map]</a:t>
             </a:r>
             <a:endParaRPr b="0" lang="en-US" sz="950" spc="-1" strike="noStrike">
               <a:solidFill>
@@ -12406,7 +12406,7 @@
                 <a:latin typeface="Calibri"/>
                 <a:ea typeface="Calibri"/>
               </a:rPr>
-              <a:t>Безопасность онлайн-покупки 200K+ ₽</a:t>
+              <a:t>[Outcome 4 из Job Map]</a:t>
             </a:r>
             <a:endParaRPr b="0" lang="en-US" sz="950" spc="-1" strike="noStrike">
               <a:solidFill>
@@ -12946,7 +12946,7 @@
                 <a:latin typeface="Calibri"/>
                 <a:ea typeface="Calibri"/>
               </a:rPr>
-              <a:t>Понимание разницы CVD / натуральный / фианит</a:t>
+              <a:t>[Outcome 5 из Job Map]</a:t>
             </a:r>
             <a:endParaRPr b="0" lang="en-US" sz="950" spc="-1" strike="noStrike">
               <a:solidFill>
@@ -13496,7 +13496,7 @@
                 <a:latin typeface="Calibri"/>
                 <a:ea typeface="Calibri"/>
               </a:rPr>
-              <a:t>Outcome 1 — критически незакрытая потребность → приоритетная возможность для OST</a:t>
+              <a:t>[Outcome с наивысшим OS] — критически незакрытая потребность → приоритетная возможность для OST</a:t>
             </a:r>
             <a:endParaRPr b="0" lang="en-US" sz="900" spc="-1" strike="noStrike">
               <a:solidFill>
@@ -15824,7 +15824,7 @@
                 <a:latin typeface="Calibri"/>
                 <a:ea typeface="Calibri"/>
               </a:rPr>
-              <a:t>Источник: PD WD 2026; финансовая модель (базовый сценарий)</a:t>
+              <a:t>Источник: задача 12; финансовая модель (базовый сценарий)</a:t>
             </a:r>
             <a:endParaRPr b="0" lang="en-US" sz="800" spc="-1" strike="noStrike">
               <a:solidFill>
@@ -15986,7 +15986,7 @@
                 <a:latin typeface="Calibri"/>
                 <a:ea typeface="Calibri"/>
               </a:rPr>
-              <a:t>0.5</a:t>
+              <a:t>[N]</a:t>
             </a:r>
             <a:endParaRPr b="0" lang="en-US" sz="2800" spc="-1" strike="noStrike">
               <a:solidFill>
@@ -16205,7 +16205,7 @@
                 <a:latin typeface="Calibri"/>
                 <a:ea typeface="Calibri"/>
               </a:rPr>
-              <a:t>25 млн ₽</a:t>
+              <a:t>[X млн ₽]</a:t>
             </a:r>
             <a:endParaRPr b="0" lang="en-US" sz="2800" spc="-1" strike="noStrike">
               <a:solidFill>
@@ -16424,7 +16424,7 @@
                 <a:latin typeface="Calibri"/>
                 <a:ea typeface="Calibri"/>
               </a:rPr>
-              <a:t>2.4%</a:t>
+              <a:t>[Y%]</a:t>
             </a:r>
             <a:endParaRPr b="0" lang="en-US" sz="2800" spc="-1" strike="noStrike">
               <a:solidFill>
@@ -16702,7 +16702,7 @@
                 <a:latin typeface="Calibri"/>
                 <a:ea typeface="Calibri"/>
               </a:rPr>
-              <a:t>Цель 1 (6–12 мес.): 10 платящих клиентов к мес. 3; GMV 25 млн ₽ за год 1; LTV/CAC ≥ 3x к мес. 6</a:t>
+              <a:t>Цель 1 (6–12 мес.): [измеримая цель с цифрой и сроком]</a:t>
             </a:r>
             <a:endParaRPr b="0" lang="en-US" sz="950" spc="-1" strike="noStrike">
               <a:solidFill>
@@ -16730,7 +16730,7 @@
                 <a:latin typeface="Calibri"/>
                 <a:ea typeface="Calibri"/>
               </a:rPr>
-              <a:t>Цель 2 (1–2 года): 200+ клиентов/год; GMV 80–100 млн ₽; pop-up шоурум в Москве</a:t>
+              <a:t>Цель 2 (1–2 года): [измеримая цель с цифрой и сроком]</a:t>
             </a:r>
             <a:endParaRPr b="0" lang="en-US" sz="950" spc="-1" strike="noStrike">
               <a:solidFill>
@@ -16758,7 +16758,7 @@
                 <a:latin typeface="Calibri"/>
                 <a:ea typeface="Calibri"/>
               </a:rPr>
-              <a:t>Цель 3 (3–5 лет): лидер ниши «крупные CVD-украшения» РФ; 10% SOM сегмента; экспансия в СНГ</a:t>
+              <a:t>Цель 3 (3–5 лет): [измеримая цель с цифрой и сроком]</a:t>
             </a:r>
             <a:endParaRPr b="0" lang="en-US" sz="950" spc="-1" strike="noStrike">
               <a:solidFill>
@@ -16786,7 +16786,7 @@
                 <a:latin typeface="Calibri"/>
                 <a:ea typeface="Calibri"/>
               </a:rPr>
-              <a:t>KPI: новые клиенты/мес, GMV, LTV/CAC, Gross Margin, Break-even month, Retention 3 мес.</a:t>
+              <a:t>KPI: [ключевые метрики, по которым отслеживается прогресс]</a:t>
             </a:r>
             <a:endParaRPr b="0" lang="en-US" sz="950" spc="-1" strike="noStrike">
               <a:solidFill>
@@ -19180,7 +19180,7 @@
                 <a:latin typeface="Calibri"/>
                 <a:ea typeface="Calibri"/>
               </a:rPr>
-              <a:t>Источник: Product Discovery Wonder Diamond, апрель 2026</a:t>
+              <a:t>Источник: Product Discovery [название проекта], [месяц год]</a:t>
             </a:r>
             <a:endParaRPr b="0" lang="en-US" sz="800" spc="-1" strike="noStrike">
               <a:solidFill>
@@ -20806,7 +20806,7 @@
                 <a:latin typeface="Calibri"/>
                 <a:ea typeface="Calibri"/>
               </a:rPr>
-              <a:t>Источник: PAC (Product Attribute Canvas); PD WD 2026</a:t>
+              <a:t>Источник: PAC (Product Attribute Canvas); задача 10</a:t>
             </a:r>
             <a:endParaRPr b="0" lang="en-US" sz="800" spc="-1" strike="noStrike">
               <a:solidFill>
@@ -21037,7 +21037,7 @@
                 <a:latin typeface="Calibri"/>
                 <a:ea typeface="Calibri"/>
               </a:rPr>
-              <a:t>Сегмент: Анна 28–42, доход 200K+ ₽/мес. Ситуация: хочет украшение с крупным бриллиантом, но нат. 5ct = 1–5M ₽</a:t>
+              <a:t>Сегмент: [персона, возраст, доход]. Ситуация: [что хочет и что мешает]</a:t>
             </a:r>
             <a:endParaRPr b="0" lang="en-US" sz="950" spc="-1" strike="noStrike">
               <a:solidFill>
@@ -21065,7 +21065,7 @@
                 <a:latin typeface="Calibri"/>
                 <a:ea typeface="Calibri"/>
               </a:rPr>
-              <a:t>Jobs: 1) Купить украшение с крупным бриллиантом 2) Выглядеть дорого и статусно 3) Убедиться в подлинности</a:t>
+              <a:t>Jobs: 1) [работа 1] 2) [работа 2] 3) [работа 3]</a:t>
             </a:r>
             <a:endParaRPr b="0" lang="en-US" sz="950" spc="-1" strike="noStrike">
               <a:solidFill>
@@ -21093,7 +21093,7 @@
                 <a:latin typeface="Calibri"/>
                 <a:ea typeface="Calibri"/>
               </a:rPr>
-              <a:t>ЦП «CVD 6ct+ от производителя с IGI» закрывает все 3 Jobs: доступная цена × размер × сертификат</a:t>
+              <a:t>ЦП «[ценностное предложение]» закрывает Jobs: [чем именно]</a:t>
             </a:r>
             <a:endParaRPr b="0" lang="en-US" sz="950" spc="-1" strike="noStrike">
               <a:solidFill>
@@ -21324,7 +21324,7 @@
                 <a:latin typeface="Calibri"/>
                 <a:ea typeface="Calibri"/>
               </a:rPr>
-              <a:t>IQ Diamonds/EcoDiam: нет камней &gt;3ct. Bright Spark: кастом долго. WD: готовые 6ct+ D2C</a:t>
+              <a:t>[Конкурент 1]: [слабость]. [Конкурент 2]: [слабость]. Мы: [чем отличаемся]</a:t>
             </a:r>
             <a:endParaRPr b="0" lang="en-US" sz="950" spc="-1" strike="noStrike">
               <a:solidFill>
@@ -21352,7 +21352,7 @@
                 <a:latin typeface="Calibri"/>
                 <a:ea typeface="Calibri"/>
               </a:rPr>
-              <a:t>Sunlight: мелкие камни (мах 1ct). SOKOLOV: нат. за 1–5M. WD — нишу 6ct+ за 150–350K никто не занял</a:t>
+              <a:t>[Конкурент 3]: [слабость]. [Конкурент 4]: [слабость]. Незанятая ниша: [описание]</a:t>
             </a:r>
             <a:endParaRPr b="0" lang="en-US" sz="950" spc="-1" strike="noStrike">
               <a:solidFill>
@@ -21380,7 +21380,7 @@
                 <a:latin typeface="Calibri"/>
                 <a:ea typeface="Calibri"/>
               </a:rPr>
-              <a:t>WD закрывает OS=16 «Доступный крупный CVD 6ct+» — ни один игрок D2C этого не делает</a:t>
+              <a:t>Мы закрываем OS=[N] «[outcome]» — [почему конкуренты этого не делают]</a:t>
             </a:r>
             <a:endParaRPr b="0" lang="en-US" sz="950" spc="-1" strike="noStrike">
               <a:solidFill>
@@ -21611,7 +21611,7 @@
                 <a:latin typeface="Calibri"/>
                 <a:ea typeface="Calibri"/>
               </a:rPr>
-              <a:t>Aha: «Это IGI-сертифицированный бриллиант 6ct за 295K вместо 3M ₽» — момент сравнения цены</a:t>
+              <a:t>Aha: «[что клиент осознаёт]» — [в какой момент это происходит]</a:t>
             </a:r>
             <a:endParaRPr b="0" lang="en-US" sz="950" spc="-1" strike="noStrike">
               <a:solidFill>
@@ -21639,7 +21639,7 @@
                 <a:latin typeface="Calibri"/>
                 <a:ea typeface="Calibri"/>
               </a:rPr>
-              <a:t>Покупка → распаковка (фирм. упаковка) → контент «моё новое украшение» → реферальный бонус 5%</a:t>
+              <a:t>[Шаг 1] → [шаг 2] → [шаг 3] → [петля роста]</a:t>
             </a:r>
             <a:endParaRPr b="0" lang="en-US" sz="950" spc="-1" strike="noStrike">
               <a:solidFill>
@@ -21870,7 +21870,7 @@
                 <a:latin typeface="Calibri"/>
                 <a:ea typeface="Calibri"/>
               </a:rPr>
-              <a:t>Фича 1: Линейка Classic 6ct+ → «Когда хочу заметное украшение, беру пусеты 6ct, чтобы не платить 2M ₽»</a:t>
+              <a:t>Фича 1: [название] → «Когда [ситуация], я [действие], чтобы [результат]»</a:t>
             </a:r>
             <a:endParaRPr b="0" lang="en-US" sz="950" spc="-1" strike="noStrike">
               <a:solidFill>
@@ -21898,7 +21898,7 @@
                 <a:latin typeface="Calibri"/>
                 <a:ea typeface="Calibri"/>
               </a:rPr>
-              <a:t>Фича 2: Price-calculator: «WD vs натуральный аналог» — визуализирует экономию</a:t>
+              <a:t>Фича 2: [название] — [какую работу закрывает]</a:t>
             </a:r>
             <a:endParaRPr b="0" lang="en-US" sz="950" spc="-1" strike="noStrike">
               <a:solidFill>
@@ -21926,7 +21926,7 @@
                 <a:latin typeface="Calibri"/>
                 <a:ea typeface="Calibri"/>
               </a:rPr>
-              <a:t>Фича 3: Программа апгрейда камня через 12 мес. — удержание + рост LTV</a:t>
+              <a:t>Фича 3: [название] — [какую работу закрывает]</a:t>
             </a:r>
             <a:endParaRPr b="0" lang="en-US" sz="950" spc="-1" strike="noStrike">
               <a:solidFill>
@@ -22232,7 +22232,7 @@
                 <a:latin typeface="Calibri"/>
                 <a:ea typeface="Calibri"/>
               </a:rPr>
-              <a:t>Источник: PD WD 2026</a:t>
+              <a:t>Источник: задача 11 (SWOT), с опорой на задачи 2 и 3</a:t>
             </a:r>
             <a:endParaRPr b="0" lang="en-US" sz="800" spc="-1" strike="noStrike">
               <a:solidFill>
@@ -22453,7 +22453,7 @@
                 <a:latin typeface="Calibri"/>
                 <a:ea typeface="Calibri"/>
               </a:rPr>
-              <a:t>Собственное производство Wonder Technology — контроль COGS, D2C</a:t>
+              <a:t>[Сильная сторона 1]</a:t>
             </a:r>
             <a:endParaRPr b="0" lang="en-US" sz="950" spc="-1" strike="noStrike">
               <a:solidFill>
@@ -22481,7 +22481,7 @@
                 <a:latin typeface="Calibri"/>
                 <a:ea typeface="Calibri"/>
               </a:rPr>
-              <a:t>Специализация на CVD 6ct+ — нет аналогов на рынке РФ (white space)</a:t>
+              <a:t>[Сильная сторона 2]</a:t>
             </a:r>
             <a:endParaRPr b="0" lang="en-US" sz="950" spc="-1" strike="noStrike">
               <a:solidFill>
@@ -22509,7 +22509,7 @@
                 <a:latin typeface="Calibri"/>
                 <a:ea typeface="Calibri"/>
               </a:rPr>
-              <a:t>D2C без посредников → Gross Margin 65% (vs 30–40% у магазинов)</a:t>
+              <a:t>[Сильная сторона 3]</a:t>
             </a:r>
             <a:endParaRPr b="0" lang="en-US" sz="950" spc="-1" strike="noStrike">
               <a:solidFill>
@@ -22537,7 +22537,7 @@
                 <a:latin typeface="Calibri"/>
                 <a:ea typeface="Calibri"/>
               </a:rPr>
-              <a:t>IGI-сертификация — международный стандарт, устраняет барьер доверия</a:t>
+              <a:t>[Сильная сторона 4]</a:t>
             </a:r>
             <a:endParaRPr b="0" lang="en-US" sz="950" spc="-1" strike="noStrike">
               <a:solidFill>
@@ -22758,7 +22758,7 @@
                 <a:latin typeface="Calibri"/>
                 <a:ea typeface="Calibri"/>
               </a:rPr>
-              <a:t>Нет клиентов и выручки — MVP стадия</a:t>
+              <a:t>[Слабая сторона 1]</a:t>
             </a:r>
             <a:endParaRPr b="0" lang="en-US" sz="950" spc="-1" strike="noStrike">
               <a:solidFill>
@@ -22786,7 +22786,7 @@
                 <a:latin typeface="Calibri"/>
                 <a:ea typeface="Calibri"/>
               </a:rPr>
-              <a:t>Нет физического шоурума — барьер для покупки 200K+ ₽ онлайн</a:t>
+              <a:t>[Слабая сторона 2]</a:t>
             </a:r>
             <a:endParaRPr b="0" lang="en-US" sz="950" spc="-1" strike="noStrike">
               <a:solidFill>
@@ -22814,7 +22814,7 @@
                 <a:latin typeface="Calibri"/>
                 <a:ea typeface="Calibri"/>
               </a:rPr>
-              <a:t>LTV/CAC = 1.84x в базовом — ниже порога 3x для pre-seed</a:t>
+              <a:t>[Слабая сторона 3]</a:t>
             </a:r>
             <a:endParaRPr b="0" lang="en-US" sz="950" spc="-1" strike="noStrike">
               <a:solidFill>
@@ -23035,7 +23035,7 @@
                 <a:latin typeface="Calibri"/>
                 <a:ea typeface="Calibri"/>
               </a:rPr>
-              <a:t>CVD занял 20% глобального рынка — категория легитимизирована</a:t>
+              <a:t>[Возможность 1 — из трендов, задача 2]</a:t>
             </a:r>
             <a:endParaRPr b="0" lang="en-US" sz="950" spc="-1" strike="noStrike">
               <a:solidFill>
@@ -23063,7 +23063,7 @@
                 <a:latin typeface="Calibri"/>
                 <a:ea typeface="Calibri"/>
               </a:rPr>
-              <a:t>E-commerce ювелирки → 35% к 2026 — попутный ветер онлайн-модели</a:t>
+              <a:t>[Возможность 2 — из трендов, задача 2]</a:t>
             </a:r>
             <a:endParaRPr b="0" lang="en-US" sz="950" spc="-1" strike="noStrike">
               <a:solidFill>
@@ -23091,7 +23091,7 @@
                 <a:latin typeface="Calibri"/>
                 <a:ea typeface="Calibri"/>
               </a:rPr>
-              <a:t>Ниша 6ct+ свободна: ни Sunlight, ни SOKOLOV, ни IQ Diamonds не предлагают</a:t>
+              <a:t>[Возможность 3 — из конкурентного ландшафта, задача 3]</a:t>
             </a:r>
             <a:endParaRPr b="0" lang="en-US" sz="950" spc="-1" strike="noStrike">
               <a:solidFill>
@@ -23312,7 +23312,7 @@
                 <a:latin typeface="Calibri"/>
                 <a:ea typeface="Calibri"/>
               </a:rPr>
-              <a:t>Sunlight может запустить крупные CVD в Cold Diamonds — ценовая война</a:t>
+              <a:t>[Угроза 1 — от конкурентов]</a:t>
             </a:r>
             <a:endParaRPr b="0" lang="en-US" sz="950" spc="-1" strike="noStrike">
               <a:solidFill>
@@ -23340,7 +23340,7 @@
                 <a:latin typeface="Calibri"/>
                 <a:ea typeface="Calibri"/>
               </a:rPr>
-              <a:t>ГИИС ДМДК (334-ФЗ с 01.03.2026) — compliance обязателен, риск стопа продаж</a:t>
+              <a:t>[Угроза 2 — регуляторная, из PESTEL]</a:t>
             </a:r>
             <a:endParaRPr b="0" lang="en-US" sz="950" spc="-1" strike="noStrike">
               <a:solidFill>
@@ -23368,7 +23368,7 @@
                 <a:latin typeface="Calibri"/>
                 <a:ea typeface="Calibri"/>
               </a:rPr>
-              <a:t>Стигма «синтетика» у аудитории 45+ ограничивает addressable market</a:t>
+              <a:t>[Угроза 3 — рыночная или поведенческая]</a:t>
             </a:r>
             <a:endParaRPr b="0" lang="en-US" sz="950" spc="-1" strike="noStrike">
               <a:solidFill>
@@ -24951,7 +24951,7 @@
                 <a:latin typeface="Calibri"/>
                 <a:ea typeface="Calibri"/>
               </a:rPr>
-              <a:t>Источник: Финансовая модель Wonder Diamond 2026, базовый сценарий</a:t>
+              <a:t>Источник: финансовая модель (задача 18c), базовый сценарий</a:t>
             </a:r>
             <a:endParaRPr b="0" lang="en-US" sz="800" spc="-1" strike="noStrike">
               <a:solidFill>
@@ -25113,7 +25113,7 @@
                 <a:latin typeface="Calibri"/>
                 <a:ea typeface="Calibri"/>
               </a:rPr>
-              <a:t>184 000 ₽</a:t>
+              <a:t>[X ₽]</a:t>
             </a:r>
             <a:endParaRPr b="0" lang="en-US" sz="2800" spc="-1" strike="noStrike">
               <a:solidFill>
@@ -25332,7 +25332,7 @@
                 <a:latin typeface="Calibri"/>
                 <a:ea typeface="Calibri"/>
               </a:rPr>
-              <a:t>100 000 ₽</a:t>
+              <a:t>[Y ₽]</a:t>
             </a:r>
             <a:endParaRPr b="0" lang="en-US" sz="2800" spc="-1" strike="noStrike">
               <a:solidFill>
@@ -25551,7 +25551,7 @@
                 <a:latin typeface="Calibri"/>
                 <a:ea typeface="Calibri"/>
               </a:rPr>
-              <a:t>1.84x ⚠️</a:t>
+              <a:t>[N.Nx]</a:t>
             </a:r>
             <a:endParaRPr b="0" lang="en-US" sz="2800" spc="-1" strike="noStrike">
               <a:solidFill>
@@ -25829,7 +25829,7 @@
                 <a:latin typeface="Calibri"/>
                 <a:ea typeface="Calibri"/>
               </a:rPr>
-              <a:t>Payback period: ~5 мес. базовый | ~2 мес. оптимист (при CAC=50K ₽)</a:t>
+              <a:t>Payback period: [N] мес. базовый | [N] мес. оптимист</a:t>
             </a:r>
             <a:endParaRPr b="0" lang="en-US" sz="950" spc="-1" strike="noStrike">
               <a:solidFill>
@@ -25857,7 +25857,7 @@
                 <a:latin typeface="Calibri"/>
                 <a:ea typeface="Calibri"/>
               </a:rPr>
-              <a:t>Runway: ~5 мес. при burn rate 400K ₽/мес и капитале 2M ₽ (требуется pre-seed)</a:t>
+              <a:t>Runway: [N] мес. при burn rate [X ₽]/мес и капитале [Y ₽]</a:t>
             </a:r>
             <a:endParaRPr b="0" lang="en-US" sz="950" spc="-1" strike="noStrike">
               <a:solidFill>
@@ -25885,7 +25885,7 @@
                 <a:latin typeface="Calibri"/>
                 <a:ea typeface="Calibri"/>
               </a:rPr>
-              <a:t>Break-even: мес. 4 базовый | мес. 2–3 оптимист — накопленный P&amp;L ≥ 0</a:t>
+              <a:t>Break-even: мес. [N] базовый | мес. [N] оптимист — накопленный P&amp;L ≥ 0</a:t>
             </a:r>
             <a:endParaRPr b="0" lang="en-US" sz="950" spc="-1" strike="noStrike">
               <a:solidFill>
@@ -25913,7 +25913,7 @@
                 <a:latin typeface="Calibri"/>
                 <a:ea typeface="Calibri"/>
               </a:rPr>
-              <a:t>Gross Margin: 65% | COGS: 35% (CVD 10% + золото 15% + производство 10%)</a:t>
+              <a:t>Gross Margin: [X%] | COGS: [Y%] ([структура себестоимости])</a:t>
             </a:r>
             <a:endParaRPr b="0" lang="en-US" sz="950" spc="-1" strike="noStrike">
               <a:solidFill>
@@ -26419,7 +26419,7 @@
                 <a:latin typeface="Calibri"/>
                 <a:ea typeface="Calibri"/>
               </a:rPr>
-              <a:t>Источник: OST (Teresa Torres); PD WD 2026</a:t>
+              <a:t>Источник: OST (Teresa Torres); задача 12</a:t>
             </a:r>
             <a:endParaRPr b="0" lang="en-US" sz="800" spc="-1" strike="noStrike">
               <a:solidFill>
@@ -26589,7 +26589,7 @@
                 <a:latin typeface="Calibri"/>
                 <a:ea typeface="Calibri"/>
               </a:rPr>
-              <a:t>GMV 25 млн ₽ за 12 мес. | 10 платящих клиентов к мес. 3 | LTV/CAC ≥ 3x к мес. 6</a:t>
+              <a:t>[Измеримая бизнес-цель: метрика, текущее → целевое значение, срок]</a:t>
             </a:r>
             <a:endParaRPr b="0" lang="en-US" sz="900" spc="-1" strike="noStrike">
               <a:solidFill>
@@ -26844,7 +26844,7 @@
                 <a:latin typeface="Calibri"/>
                 <a:ea typeface="Calibri"/>
               </a:rPr>
-              <a:t>Доступный CVD 6ct+ | OS=16 🔴 Приоритет</a:t>
+              <a:t>[Возможность 1 из задачи 7] | OS=[N] 🔴 Приоритет</a:t>
             </a:r>
             <a:endParaRPr b="0" lang="en-US" sz="800" spc="-1" strike="noStrike">
               <a:solidFill>
@@ -27058,7 +27058,7 @@
                 <a:latin typeface="Calibri"/>
                 <a:ea typeface="Calibri"/>
               </a:rPr>
-              <a:t>Уверенность в подлинности (IGI) | OS=15</a:t>
+              <a:t>[Возможность 2 из задачи 7] | OS=[N]</a:t>
             </a:r>
             <a:endParaRPr b="0" lang="en-US" sz="800" spc="-1" strike="noStrike">
               <a:solidFill>
@@ -27272,7 +27272,7 @@
                 <a:latin typeface="Calibri"/>
                 <a:ea typeface="Calibri"/>
               </a:rPr>
-              <a:t>Социальный сигнал «смотрится дорого» | OS=14</a:t>
+              <a:t>[Возможность 3 из задачи 7] | OS=[N]</a:t>
             </a:r>
             <a:endParaRPr b="0" lang="en-US" sz="800" spc="-1" strike="noStrike">
               <a:solidFill>
@@ -27510,7 +27510,7 @@
                 <a:latin typeface="Calibri"/>
                 <a:ea typeface="Calibri"/>
               </a:rPr>
-              <a:t>Готовая линейка Classic: пусеты 6ct, кольца 3ct, подвески 3ct с IGI</a:t>
+              <a:t>[Решение A: что именно строим и для кого]</a:t>
             </a:r>
             <a:endParaRPr b="0" lang="en-US" sz="850" spc="-1" strike="noStrike">
               <a:solidFill>
@@ -27683,7 +27683,7 @@
                 <a:latin typeface="Calibri"/>
                 <a:ea typeface="Calibri"/>
               </a:rPr>
-              <a:t>Smoke Test: Instagram «6ct за 295K», 50K ₽, 7 дней, CTR ≥ 2%</a:t>
+              <a:t>[Метод], [бюджет], [срок], критерий [метрика ≥ значение]</a:t>
             </a:r>
             <a:endParaRPr b="0" lang="en-US" sz="750" spc="-1" strike="noStrike">
               <a:solidFill>
@@ -27815,7 +27815,7 @@
                 <a:latin typeface="Calibri"/>
                 <a:ea typeface="Calibri"/>
               </a:rPr>
-              <a:t>Price-calculator на сайте: «WD 6ct vs натуральный аналог» — экономия в ₽</a:t>
+              <a:t>[Решение B: что именно строим и для кого]</a:t>
             </a:r>
             <a:endParaRPr b="0" lang="en-US" sz="850" spc="-1" strike="noStrike">
               <a:solidFill>
@@ -27988,7 +27988,7 @@
                 <a:latin typeface="Calibri"/>
                 <a:ea typeface="Calibri"/>
               </a:rPr>
-              <a:t>Pre-sale: 5 заявок через Telegram за 2 нед., 0 ₽</a:t>
+              <a:t>[Метод], [бюджет], [срок], критерий [метрика ≥ значение]</a:t>
             </a:r>
             <a:endParaRPr b="0" lang="en-US" sz="750" spc="-1" strike="noStrike">
               <a:solidFill>
@@ -28120,7 +28120,7 @@
                 <a:latin typeface="Calibri"/>
                 <a:ea typeface="Calibri"/>
               </a:rPr>
-              <a:t>Программа апгрейда камня через 12 мес. — retention + LTV</a:t>
+              <a:t>[Решение C: что именно строим и для кого]</a:t>
             </a:r>
             <a:endParaRPr b="0" lang="en-US" sz="850" spc="-1" strike="noStrike">
               <a:solidFill>
@@ -28293,7 +28293,7 @@
                 <a:latin typeface="Calibri"/>
                 <a:ea typeface="Calibri"/>
               </a:rPr>
-              <a:t>Wizard of Oz: ручная «подписка на апгрейд» для первых 20</a:t>
+              <a:t>[Метод], [бюджет], [срок], критерий [метрика ≥ значение]</a:t>
             </a:r>
             <a:endParaRPr b="0" lang="en-US" sz="750" spc="-1" strike="noStrike">
               <a:solidFill>
@@ -30304,7 +30304,7 @@
                 <a:latin typeface="Calibri"/>
                 <a:ea typeface="Calibri"/>
               </a:rPr>
-              <a:t>Источник: Альтернативный сценарий — гибридная модель (D2C online + pop-up showroom)</a:t>
+              <a:t>Источник: альтернативный сценарий из задачи 13; скоринг из задачи 14</a:t>
             </a:r>
             <a:endParaRPr b="0" lang="en-US" sz="800" spc="-1" strike="noStrike">
               <a:solidFill>
@@ -30679,7 +30679,7 @@
                 <a:latin typeface="Calibri"/>
                 <a:ea typeface="Calibri"/>
               </a:rPr>
-              <a:t>Анна 28–42, доход 200K+, МСК/СПб, onlineonly</a:t>
+              <a:t>[Сегмент в текущем сценарии]</a:t>
             </a:r>
             <a:endParaRPr b="0" lang="en-US" sz="950" spc="-1" strike="noStrike">
               <a:solidFill>
@@ -30785,7 +30785,7 @@
                 <a:latin typeface="Calibri"/>
                 <a:ea typeface="Calibri"/>
               </a:rPr>
-              <a:t>+ Анна 28–50 (до 50 лет с расширением); MСК/СПб/Казань/Екб; готова посетить pop-up для покупки 200K+</a:t>
+              <a:t>[Сегмент в альтернативном сценарии — что меняется]</a:t>
             </a:r>
             <a:endParaRPr b="0" lang="en-US" sz="950" spc="-1" strike="noStrike">
               <a:solidFill>
@@ -31005,7 +31005,7 @@
                 <a:latin typeface="Calibri"/>
                 <a:ea typeface="Calibri"/>
               </a:rPr>
-              <a:t>«CVD 6ct+ онлайн напрямую от производителя — в 10–50× дешевле»</a:t>
+              <a:t>«[Ценностное предложение в текущем сценарии]»</a:t>
             </a:r>
             <a:endParaRPr b="0" lang="en-US" sz="950" spc="-1" strike="noStrike">
               <a:solidFill>
@@ -31111,7 +31111,7 @@
                 <a:latin typeface="Calibri"/>
                 <a:ea typeface="Calibri"/>
               </a:rPr>
-              <a:t>«CVD 6ct+ онлайн или в нашем pop-up шоуруме Москвы — примерь до покупки; IGI-сертификат»</a:t>
+              <a:t>«[Ценностное предложение в альтернативном сценарии]»</a:t>
             </a:r>
             <a:endParaRPr b="0" lang="en-US" sz="950" spc="-1" strike="noStrike">
               <a:solidFill>
@@ -31331,7 +31331,7 @@
                 <a:latin typeface="Calibri"/>
                 <a:ea typeface="Calibri"/>
               </a:rPr>
-              <a:t>Купить украшение с крупным бриллиантом онлайн без физической примерки</a:t>
+              <a:t>[Job-to-be-Done в текущем сценарии]</a:t>
             </a:r>
             <a:endParaRPr b="0" lang="en-US" sz="950" spc="-1" strike="noStrike">
               <a:solidFill>
@@ -31437,7 +31437,7 @@
                 <a:latin typeface="Calibri"/>
                 <a:ea typeface="Calibri"/>
               </a:rPr>
-              <a:t>Купить или примерить украшение с крупным бриллиантом, снизив риск онлайн-покупки 200K+ через шоурум</a:t>
+              <a:t>[Job-to-be-Done в альтернативном сценарии]</a:t>
             </a:r>
             <a:endParaRPr b="0" lang="en-US" sz="950" spc="-1" strike="noStrike">
               <a:solidFill>
@@ -31657,7 +31657,7 @@
                 <a:latin typeface="Calibri"/>
                 <a:ea typeface="Calibri"/>
               </a:rPr>
-              <a:t>Разовые продажи онлайн, средний чек 250K ₽</a:t>
+              <a:t>[Бизнес-модель в текущем сценарии: монетизация, чек]</a:t>
             </a:r>
             <a:endParaRPr b="0" lang="en-US" sz="950" spc="-1" strike="noStrike">
               <a:solidFill>
@@ -31763,7 +31763,7 @@
                 <a:latin typeface="Calibri"/>
                 <a:ea typeface="Calibri"/>
               </a:rPr>
-              <a:t>Разовые продажи + pop-up со встречей → средний чек 300K+ (upsell при личной консультации); LTV растёт на 20–30%</a:t>
+              <a:t>[Бизнес-модель в альтернативном сценарии: что меняется в экономике]</a:t>
             </a:r>
             <a:endParaRPr b="0" lang="en-US" sz="950" spc="-1" strike="noStrike">
               <a:solidFill>
@@ -32126,7 +32126,7 @@
                 <a:latin typeface="Calibri"/>
                 <a:ea typeface="Calibri"/>
               </a:rPr>
-              <a:t>Источник: RICE = (Reach × Impact × Confidence) / Effort; PD WD 2026</a:t>
+              <a:t>Источник: RICE = (Reach × Impact × Confidence) / Effort; задача 14</a:t>
             </a:r>
             <a:endParaRPr b="0" lang="en-US" sz="800" spc="-1" strike="noStrike">
               <a:solidFill>
@@ -32925,7 +32925,7 @@
                 <a:latin typeface="Calibri"/>
                 <a:ea typeface="Calibri"/>
               </a:rPr>
-              <a:t>Возможность A: Доступный крупный CVD 6ct+ (OS=16) | R=400 (лидов/мес) × I=3 × C=0.7 / E=2 = 420 | 🔴 ТОП</a:t>
+              <a:t>Возможность A: [название] (OS=[N]) | R=[охват] × I=[impact] × C=[conf] / E=[effort] = [score] | 🔴 ТОП</a:t>
             </a:r>
             <a:endParaRPr b="0" lang="en-US" sz="850" spc="-1" strike="noStrike">
               <a:solidFill>
@@ -33561,7 +33561,7 @@
                 <a:latin typeface="Calibri"/>
                 <a:ea typeface="Calibri"/>
               </a:rPr>
-              <a:t>Возможность B: Уверенность в подлинности через IGI (OS=15) | R=400 × I=2 × C=0.9 / E=1 = 720 | 🟠 ВЫСОКИЙ</a:t>
+              <a:t>Возможность B: [название] (OS=[N]) | R=[охват] × I=[impact] × C=[conf] / E=[effort] = [score] | 🟠 ВЫСОКИЙ</a:t>
             </a:r>
             <a:endParaRPr b="0" lang="en-US" sz="850" spc="-1" strike="noStrike">
               <a:solidFill>
@@ -34197,7 +34197,7 @@
                 <a:latin typeface="Calibri"/>
                 <a:ea typeface="Calibri"/>
               </a:rPr>
-              <a:t>Возможность C: «Смотрится дорого» — соц. сигнал (OS=14) | R=300 × I=2 × C=0.5 / E=3 = 100 | 🟡 СРЕДНИЙ</a:t>
+              <a:t>Возможность C: [название] (OS=[N]) | R=[охват] × I=[impact] × C=[conf] / E=[effort] = [score] | 🟡 СРЕДНИЙ</a:t>
             </a:r>
             <a:endParaRPr b="0" lang="en-US" sz="850" spc="-1" strike="noStrike">
               <a:solidFill>
@@ -35260,7 +35260,7 @@
                 <a:latin typeface="Calibri"/>
                 <a:ea typeface="Calibri"/>
               </a:rPr>
-              <a:t>Источник: Ассоциация ювелиров РФ 2025; INFOLine 2025</a:t>
+              <a:t>Источник: [отраслевые отчёты и статистика по рынку — задачи 1, 5]</a:t>
             </a:r>
             <a:endParaRPr b="0" lang="en-US" sz="800" spc="-1" strike="noStrike">
               <a:solidFill>
@@ -35480,7 +35480,7 @@
                 <a:latin typeface="Calibri"/>
                 <a:ea typeface="Calibri"/>
               </a:rPr>
-              <a:t>539 млрд ₽</a:t>
+              <a:t>[X млрд ₽]</a:t>
             </a:r>
             <a:endParaRPr b="0" lang="en-US" sz="1900" spc="-1" strike="noStrike">
               <a:solidFill>
@@ -35700,7 +35700,7 @@
                 <a:latin typeface="Calibri"/>
                 <a:ea typeface="Calibri"/>
               </a:rPr>
-              <a:t>2,1 млрд ₽</a:t>
+              <a:t>[Y млрд ₽]</a:t>
             </a:r>
             <a:endParaRPr b="0" lang="en-US" sz="1900" spc="-1" strike="noStrike">
               <a:solidFill>
@@ -35920,7 +35920,7 @@
                 <a:latin typeface="Calibri"/>
                 <a:ea typeface="Calibri"/>
               </a:rPr>
-              <a:t>50 млн ₽</a:t>
+              <a:t>[Z млн ₽]</a:t>
             </a:r>
             <a:endParaRPr b="0" lang="en-US" sz="1900" spc="-1" strike="noStrike">
               <a:solidFill>
@@ -35977,7 +35977,7 @@
                 <a:latin typeface="Calibri"/>
                 <a:ea typeface="Calibri"/>
               </a:rPr>
-              <a:t>Top-down: 539B × 15% премиум × 5% CVD × 26% онлайн = 2,1 млрд ₽. Bottom-up: 300K покупателей × 0,4 × 250K × 7% = 2,1 млрд ₽. Расхождение 1× ✅</a:t>
+              <a:t>Top-down: [расчёт по доле сегмента] = [Y]. Bottom-up: [клиенты × чек × частота] = [Y]. Расхождение [N]× [✅ / ⚠️ пересмотреть допущения]</a:t>
             </a:r>
             <a:endParaRPr b="0" lang="en-US" sz="850" spc="-1" strike="noStrike">
               <a:solidFill>
@@ -38021,7 +38021,7 @@
                 <a:latin typeface="Calibri"/>
                 <a:ea typeface="Calibri"/>
               </a:rPr>
-              <a:t>Источник: Sean Ellis Test; PMF-пороги Superhuman; benchmarks (a16z, b2b SaaS); PD WD 2026</a:t>
+              <a:t>Источник: Sean Ellis Test; отраслевые бенчмарки (a16z, B2B SaaS); задача 17</a:t>
             </a:r>
             <a:endParaRPr b="0" lang="en-US" sz="800" spc="-1" strike="noStrike">
               <a:solidFill>
@@ -40594,7 +40594,7 @@
                 <a:latin typeface="Calibri"/>
                 <a:ea typeface="Calibri"/>
               </a:rPr>
-              <a:t>Sean Ellis Test (для WD): «Как вы себя почувствуете, если Wonder Diamond больше не сможете заказывать?» → цель ≥ 40% «очень разочарован(а)» после 10-20 первых продаж</a:t>
+              <a:t>Sean Ellis Test: «Как вы себя почувствуете, если [продукт] станет недоступен?» → цель ≥ 40% «очень разочарован(а)» после 10–20 первых продаж</a:t>
             </a:r>
             <a:endParaRPr b="0" lang="en-US" sz="850" spc="-1" strike="noStrike">
               <a:solidFill>
@@ -45142,7 +45142,7 @@
                 <a:latin typeface="Calibri"/>
                 <a:ea typeface="Calibri"/>
               </a:rPr>
-              <a:t>5–7 глубинных интервью (The Mom Test) с ЦА «Анна» за 2 нед. Цель: 5/7 подтверждают боль. 0 ₽</a:t>
+              <a:t>5–7 глубинных интервью (The Mom Test) с [сегмент] за [срок]. Цель: [N/M] подтверждают боль. [бюджет]</a:t>
             </a:r>
             <a:endParaRPr b="0" lang="en-US" sz="900" spc="-1" strike="noStrike">
               <a:solidFill>
@@ -45362,7 +45362,7 @@
                 <a:latin typeface="Calibri"/>
                 <a:ea typeface="Calibri"/>
               </a:rPr>
-              <a:t>Smoke Test Instagram: «6ct за 295K vs нат. за 3M». 50 000 ₽, 7 дней. CTR ≥ 2%</a:t>
+              <a:t>Smoke Test [канал]: «[оффер]». [бюджет], [срок]. Критерий: [метрика ≥ значение]</a:t>
             </a:r>
             <a:endParaRPr b="0" lang="en-US" sz="900" spc="-1" strike="noStrike">
               <a:solidFill>
@@ -45582,7 +45582,7 @@
                 <a:latin typeface="Calibri"/>
                 <a:ea typeface="Calibri"/>
               </a:rPr>
-              <a:t>Опрос 30–50 респондентов на лендинге WD после «Что такое CVD» — верификация OS</a:t>
+              <a:t>Опрос 30–50 респондентов [канал сбора] — верификация OS из задачи 7</a:t>
             </a:r>
             <a:endParaRPr b="0" lang="en-US" sz="900" spc="-1" strike="noStrike">
               <a:solidFill>
@@ -45802,7 +45802,7 @@
                 <a:latin typeface="Calibri"/>
                 <a:ea typeface="Calibri"/>
               </a:rPr>
-              <a:t>Приоритет: «Доступный CVD 6ct+» (OS=16). Решения: линейка Classic + price-calculator</a:t>
+              <a:t>Приоритет: «[возможность]» (OS=[N]). Решения: [решение 1] + [решение 2]</a:t>
             </a:r>
             <a:endParaRPr b="0" lang="en-US" sz="900" spc="-1" strike="noStrike">
               <a:solidFill>
@@ -46022,7 +46022,7 @@
                 <a:latin typeface="Calibri"/>
                 <a:ea typeface="Calibri"/>
               </a:rPr>
-              <a:t>Value Validation после 10 продаж: Sean Ellis Test («если WD исчез?» ≥ 40% очень разочарованы)</a:t>
+              <a:t>Value Validation после [N] продаж: Sean Ellis Test (цель ≥ 40% «очень разочарованы»)</a:t>
             </a:r>
             <a:endParaRPr b="0" lang="en-US" sz="900" spc="-1" strike="noStrike">
               <a:solidFill>
@@ -46079,7 +46079,7 @@
                 <a:latin typeface="Calibri"/>
                 <a:ea typeface="Calibri"/>
               </a:rPr>
-              <a:t>Wonder Diamond  ·  wonderdiamond.ru  ·  Апрель 2026</a:t>
+              <a:t>[Название проекта]  ·  [сайт]  ·  [месяц год]</a:t>
             </a:r>
             <a:endParaRPr b="0" lang="en-US" sz="800" spc="-1" strike="noStrike">
               <a:solidFill>
@@ -46385,7 +46385,7 @@
                 <a:latin typeface="Calibri"/>
                 <a:ea typeface="Calibri"/>
               </a:rPr>
-              <a:t>Источник: INFOLine 2025; Sokolov Analytics; Ассоциация ювелиров</a:t>
+              <a:t>Источник: [источники по динамике и прогнозу рынка — задача 1]</a:t>
             </a:r>
             <a:endParaRPr b="0" lang="en-US" sz="800" spc="-1" strike="noStrike">
               <a:solidFill>
@@ -46766,7 +46766,7 @@
                 <a:latin typeface="Calibri"/>
                 <a:ea typeface="Calibri"/>
               </a:rPr>
-              <a:t>15–17%</a:t>
+              <a:t>[X–Y%]</a:t>
             </a:r>
             <a:endParaRPr b="0" lang="en-US" sz="2800" spc="-1" strike="noStrike">
               <a:solidFill>
@@ -46985,7 +46985,7 @@
                 <a:latin typeface="Calibri"/>
                 <a:ea typeface="Calibri"/>
               </a:rPr>
-              <a:t>6 ключевых</a:t>
+              <a:t>[N] ключевых</a:t>
             </a:r>
             <a:endParaRPr b="0" lang="en-US" sz="2800" spc="-1" strike="noStrike">
               <a:solidFill>
@@ -47263,7 +47263,7 @@
                 <a:latin typeface="Calibri"/>
                 <a:ea typeface="Calibri"/>
               </a:rPr>
-              <a:t>CAGR 15–17%/год за 2023–2025. Источник: INFOLine, Ассоциация ювелиров РФ</a:t>
+              <a:t>CAGR [X–Y%]/год за [период]. Источник: [источник]</a:t>
             </a:r>
             <a:endParaRPr b="0" lang="en-US" sz="950" spc="-1" strike="noStrike">
               <a:solidFill>
@@ -47291,7 +47291,7 @@
                 <a:latin typeface="Calibri"/>
                 <a:ea typeface="Calibri"/>
               </a:rPr>
-              <a:t>Прогноз: 2026: 620 млрд ₽ → 2028: ~850 млрд (при сохранении 16% CAGR)</a:t>
+              <a:t>Прогноз: [год]: [объём] → [год]: [объём] (при сохранении [Z%] CAGR)</a:t>
             </a:r>
             <a:endParaRPr b="0" lang="en-US" sz="950" spc="-1" strike="noStrike">
               <a:solidFill>
@@ -47319,7 +47319,7 @@
                 <a:latin typeface="Calibri"/>
                 <a:ea typeface="Calibri"/>
               </a:rPr>
-              <a:t>Драйверы: рост цены золота (+45%), e-commerce +35%, премиализация, CVD занял 20% рынка</a:t>
+              <a:t>Драйверы: [драйвер 1], [драйвер 2], [драйвер 3]</a:t>
             </a:r>
             <a:endParaRPr b="0" lang="en-US" sz="950" spc="-1" strike="noStrike">
               <a:solidFill>
@@ -47347,7 +47347,7 @@
                 <a:latin typeface="Calibri"/>
                 <a:ea typeface="Calibri"/>
               </a:rPr>
-              <a:t>Риски: высокая ключевая ставка ЦБ, падение покуп. способности, падение RAPI натуральных −10%</a:t>
+              <a:t>Риски: [риск 1], [риск 2], [риск 3]</a:t>
             </a:r>
             <a:endParaRPr b="0" lang="en-US" sz="950" spc="-1" strike="noStrike">
               <a:solidFill>
@@ -47653,7 +47653,7 @@
                 <a:latin typeface="Calibri"/>
                 <a:ea typeface="Calibri"/>
               </a:rPr>
-              <a:t>Источник: Ассоциация ювелиров 2025; INFOLine; Financial Times; Sokolov</a:t>
+              <a:t>Источник: [источники по трендам — задача 2]</a:t>
             </a:r>
             <a:endParaRPr b="0" lang="en-US" sz="800" spc="-1" strike="noStrike">
               <a:solidFill>
@@ -47874,7 +47874,7 @@
                 <a:latin typeface="Calibri"/>
                 <a:ea typeface="Calibri"/>
               </a:rPr>
-              <a:t>CVD занял ~20% бриллиантового рынка глобально (было 0% в 2015) — категория легитимизируется. Снижает барьер недоверия для новых CVD-брендов</a:t>
+              <a:t>[Технологический тренд: суть, цифра с источником, следствие для продукта]</a:t>
             </a:r>
             <a:endParaRPr b="0" lang="en-US" sz="950" spc="-1" strike="noStrike">
               <a:solidFill>
@@ -48095,7 +48095,7 @@
                 <a:latin typeface="Calibri"/>
                 <a:ea typeface="Calibri"/>
               </a:rPr>
-              <a:t>E-commerce ювелирки растёт: 26% → 35% к 2026 (Sokolov). Премиализация: доля украшений с камнями 42% → 45–50% (Ювелир.INFO)</a:t>
+              <a:t>[Поведенческий тренд: суть, цифра с источником, следствие для продукта]</a:t>
             </a:r>
             <a:endParaRPr b="0" lang="en-US" sz="950" spc="-1" strike="noStrike">
               <a:solidFill>
@@ -48316,7 +48316,7 @@
                 <a:latin typeface="Calibri"/>
                 <a:ea typeface="Calibri"/>
               </a:rPr>
-              <a:t>Закон 334-ФЗ (с 01.03.2026): реестр объектов розницы в ГИИС ДМДК. Обязательная 2D-маркировка (с сент. 2025)</a:t>
+              <a:t>[Регуляторный тренд: норма, дата вступления, следствие для продукта]</a:t>
             </a:r>
             <a:endParaRPr b="0" lang="en-US" sz="950" spc="-1" strike="noStrike">
               <a:solidFill>
@@ -48537,7 +48537,7 @@
                 <a:latin typeface="Calibri"/>
                 <a:ea typeface="Calibri"/>
               </a:rPr>
-              <a:t>Рост цены золота +45% за 2024 → рост COGS оправ. RAPI натуральных бриллиантов −10% за 2025 → рынок натуральных слабеет</a:t>
+              <a:t>[Экономический тренд: суть, цифра с источником, следствие для продукта]</a:t>
             </a:r>
             <a:endParaRPr b="0" lang="en-US" sz="950" spc="-1" strike="noStrike">
               <a:solidFill>
@@ -50306,7 +50306,7 @@
                 <a:latin typeface="Calibri"/>
                 <a:ea typeface="Calibri"/>
               </a:rPr>
-              <a:t>Источник: Сайты конкурентов, VC.ru, отзывы Ozon/Wildberries; PD WD 2026</a:t>
+              <a:t>Источник: [сайты конкурентов, отзывы, отраслевые публикации — задача 3]</a:t>
             </a:r>
             <a:endParaRPr b="0" lang="en-US" sz="800" spc="-1" strike="noStrike">
               <a:solidFill>
@@ -50527,7 +50527,7 @@
                 <a:latin typeface="Calibri"/>
                 <a:ea typeface="Calibri"/>
               </a:rPr>
-              <a:t>IQ Diamonds · Bright Spark · EcoDiam</a:t>
+              <a:t>[Прямой 1] · [Прямой 2] · [Прямой 3]</a:t>
             </a:r>
             <a:endParaRPr b="0" lang="en-US" sz="950" spc="-1" strike="noStrike">
               <a:solidFill>
@@ -50748,7 +50748,7 @@
                 <a:latin typeface="Calibri"/>
                 <a:ea typeface="Calibri"/>
               </a:rPr>
-              <a:t>Sunlight Cold Diamonds · Gems Hunter</a:t>
+              <a:t>[Косвенный 1] · [Косвенный 2]</a:t>
             </a:r>
             <a:endParaRPr b="0" lang="en-US" sz="950" spc="-1" strike="noStrike">
               <a:solidFill>
@@ -50969,7 +50969,7 @@
                 <a:latin typeface="Calibri"/>
                 <a:ea typeface="Calibri"/>
               </a:rPr>
-              <a:t>SOKOLOV (натуральные бриллианты) · Серебро и бижутерия</a:t>
+              <a:t>[Вытеснитель 1] · [Вытеснитель 2]</a:t>
             </a:r>
             <a:endParaRPr b="0" lang="en-US" sz="950" spc="-1" strike="noStrike">
               <a:solidFill>
@@ -51190,7 +51190,7 @@
                 <a:latin typeface="Calibri"/>
                 <a:ea typeface="Calibri"/>
               </a:rPr>
-              <a:t>Sunlight — 1 500+ магазинов РФ, все маркетплейсы, ~30% рынка</a:t>
+              <a:t>[Конкурент по каналам: охват, каналы дистрибуции, доля рынка]</a:t>
             </a:r>
             <a:endParaRPr b="0" lang="en-US" sz="950" spc="-1" strike="noStrike">
               <a:solidFill>
@@ -51787,7 +51787,7 @@
                           </a:solidFill>
                           <a:latin typeface="Arial"/>
                         </a:rPr>
-                        <a:t>IQ Diamonds</a:t>
+                        <a:t>[Конкурент 1]</a:t>
                       </a:r>
                       <a:endParaRPr b="0" lang="en-US" sz="900" spc="-1" strike="noStrike">
                         <a:solidFill>
@@ -51845,7 +51845,7 @@
                           </a:solidFill>
                           <a:latin typeface="Arial"/>
                         </a:rPr>
-                        <a:t>СПб, онлайн РФ</a:t>
+                        <a:t>[рынок / гео]</a:t>
                       </a:r>
                       <a:endParaRPr b="0" lang="en-US" sz="900" spc="-1" strike="noStrike">
                         <a:solidFill>
@@ -51903,7 +51903,7 @@
                           </a:solidFill>
                           <a:latin typeface="Arial"/>
                         </a:rPr>
-                        <a:t>20K–200K ₽</a:t>
+                        <a:t>[цена]</a:t>
                       </a:r>
                       <a:endParaRPr b="0" lang="en-US" sz="900" spc="-1" strike="noStrike">
                         <a:solidFill>
@@ -51961,7 +51961,7 @@
                           </a:solidFill>
                           <a:latin typeface="Arial"/>
                         </a:rPr>
-                        <a:t>~3 000</a:t>
+                        <a:t>[клиенты]</a:t>
                       </a:r>
                       <a:endParaRPr b="0" lang="en-US" sz="900" spc="-1" strike="noStrike">
                         <a:solidFill>
@@ -52019,7 +52019,7 @@
                           </a:solidFill>
                           <a:latin typeface="Arial"/>
                         </a:rPr>
-                        <a:t>~200M ₽</a:t>
+                        <a:t>[выручка]</a:t>
                       </a:r>
                       <a:endParaRPr b="0" lang="en-US" sz="900" spc="-1" strike="noStrike">
                         <a:solidFill>
@@ -52077,7 +52077,7 @@
                           </a:solidFill>
                           <a:latin typeface="Arial"/>
                         </a:rPr>
-                        <a:t>Полная коллекция CVD, шоурум</a:t>
+                        <a:t>[ключевые фичи]</a:t>
                       </a:r>
                       <a:endParaRPr b="0" lang="en-US" sz="900" spc="-1" strike="noStrike">
                         <a:solidFill>
@@ -52135,7 +52135,7 @@
                           </a:solidFill>
                           <a:latin typeface="Arial"/>
                         </a:rPr>
-                        <a:t>Нет камней &gt; 3ct</a:t>
+                        <a:t>[слабость]</a:t>
                       </a:r>
                       <a:endParaRPr b="0" lang="en-US" sz="900" spc="-1" strike="noStrike">
                         <a:solidFill>
@@ -52195,7 +52195,7 @@
                           </a:solidFill>
                           <a:latin typeface="Arial"/>
                         </a:rPr>
-                        <a:t>Bright Spark</a:t>
+                        <a:t>[Конкурент 2]</a:t>
                       </a:r>
                       <a:endParaRPr b="0" lang="en-US" sz="900" spc="-1" strike="noStrike">
                         <a:solidFill>
@@ -52253,7 +52253,7 @@
                           </a:solidFill>
                           <a:latin typeface="Arial"/>
                         </a:rPr>
-                        <a:t>МСК, СПб, онлайн</a:t>
+                        <a:t>[рынок / гео]</a:t>
                       </a:r>
                       <a:endParaRPr b="0" lang="en-US" sz="900" spc="-1" strike="noStrike">
                         <a:solidFill>
@@ -52311,7 +52311,7 @@
                           </a:solidFill>
                           <a:latin typeface="Arial"/>
                         </a:rPr>
-                        <a:t>50K–300K ₽</a:t>
+                        <a:t>[цена]</a:t>
                       </a:r>
                       <a:endParaRPr b="0" lang="en-US" sz="900" spc="-1" strike="noStrike">
                         <a:solidFill>
@@ -52369,7 +52369,7 @@
                           </a:solidFill>
                           <a:latin typeface="Arial"/>
                         </a:rPr>
-                        <a:t>~500</a:t>
+                        <a:t>[клиенты]</a:t>
                       </a:r>
                       <a:endParaRPr b="0" lang="en-US" sz="900" spc="-1" strike="noStrike">
                         <a:solidFill>
@@ -52427,7 +52427,7 @@
                           </a:solidFill>
                           <a:latin typeface="Arial"/>
                         </a:rPr>
-                        <a:t>~50M ₽</a:t>
+                        <a:t>[выручка]</a:t>
                       </a:r>
                       <a:endParaRPr b="0" lang="en-US" sz="900" spc="-1" strike="noStrike">
                         <a:solidFill>
@@ -52485,7 +52485,7 @@
                           </a:solidFill>
                           <a:latin typeface="Arial"/>
                         </a:rPr>
-                        <a:t>Авторский кастом, шоурумы</a:t>
+                        <a:t>[ключевые фичи]</a:t>
                       </a:r>
                       <a:endParaRPr b="0" lang="en-US" sz="900" spc="-1" strike="noStrike">
                         <a:solidFill>
@@ -52543,7 +52543,7 @@
                           </a:solidFill>
                           <a:latin typeface="Arial"/>
                         </a:rPr>
-                        <a:t>Кастом 2–4 нед.; нет готовых 6ct+</a:t>
+                        <a:t>[слабость]</a:t>
                       </a:r>
                       <a:endParaRPr b="0" lang="en-US" sz="900" spc="-1" strike="noStrike">
                         <a:solidFill>
@@ -52603,7 +52603,7 @@
                           </a:solidFill>
                           <a:latin typeface="Arial"/>
                         </a:rPr>
-                        <a:t>EcoDiam</a:t>
+                        <a:t>[Конкурент 3]</a:t>
                       </a:r>
                       <a:endParaRPr b="0" lang="en-US" sz="900" spc="-1" strike="noStrike">
                         <a:solidFill>
@@ -52661,7 +52661,7 @@
                           </a:solidFill>
                           <a:latin typeface="Arial"/>
                         </a:rPr>
-                        <a:t>Онлайн РФ</a:t>
+                        <a:t>[рынок / гео]</a:t>
                       </a:r>
                       <a:endParaRPr b="0" lang="en-US" sz="900" spc="-1" strike="noStrike">
                         <a:solidFill>
@@ -52719,7 +52719,7 @@
                           </a:solidFill>
                           <a:latin typeface="Arial"/>
                         </a:rPr>
-                        <a:t>10K–150K ₽</a:t>
+                        <a:t>[цена]</a:t>
                       </a:r>
                       <a:endParaRPr b="0" lang="en-US" sz="900" spc="-1" strike="noStrike">
                         <a:solidFill>
@@ -52777,7 +52777,7 @@
                           </a:solidFill>
                           <a:latin typeface="Arial"/>
                         </a:rPr>
-                        <a:t>~1 000</a:t>
+                        <a:t>[клиенты]</a:t>
                       </a:r>
                       <a:endParaRPr b="0" lang="en-US" sz="900" spc="-1" strike="noStrike">
                         <a:solidFill>
@@ -52835,7 +52835,7 @@
                           </a:solidFill>
                           <a:latin typeface="Arial"/>
                         </a:rPr>
-                        <a:t>~30M ₽</a:t>
+                        <a:t>[выручка]</a:t>
                       </a:r>
                       <a:endParaRPr b="0" lang="en-US" sz="900" spc="-1" strike="noStrike">
                         <a:solidFill>
@@ -52893,7 +52893,7 @@
                           </a:solidFill>
                           <a:latin typeface="Arial"/>
                         </a:rPr>
-                        <a:t>Широкий выбор камней</a:t>
+                        <a:t>[ключевые фичи]</a:t>
                       </a:r>
                       <a:endParaRPr b="0" lang="en-US" sz="900" spc="-1" strike="noStrike">
                         <a:solidFill>
@@ -52951,7 +52951,7 @@
                           </a:solidFill>
                           <a:latin typeface="Arial"/>
                         </a:rPr>
-                        <a:t>Фокус на камни, не ювелирка</a:t>
+                        <a:t>[слабость]</a:t>
                       </a:r>
                       <a:endParaRPr b="0" lang="en-US" sz="900" spc="-1" strike="noStrike">
                         <a:solidFill>
@@ -53011,7 +53011,7 @@
                           </a:solidFill>
                           <a:latin typeface="Arial"/>
                         </a:rPr>
-                        <a:t>Sunlight Cold Diamonds</a:t>
+                        <a:t>[Конкурент 4]</a:t>
                       </a:r>
                       <a:endParaRPr b="0" lang="en-US" sz="900" spc="-1" strike="noStrike">
                         <a:solidFill>
@@ -53069,7 +53069,7 @@
                           </a:solidFill>
                           <a:latin typeface="Arial"/>
                         </a:rPr>
-                        <a:t>Вся РФ</a:t>
+                        <a:t>[рынок / гео]</a:t>
                       </a:r>
                       <a:endParaRPr b="0" lang="en-US" sz="900" spc="-1" strike="noStrike">
                         <a:solidFill>
@@ -53127,7 +53127,7 @@
                           </a:solidFill>
                           <a:latin typeface="Arial"/>
                         </a:rPr>
-                        <a:t>15K–80K ₽</a:t>
+                        <a:t>[цена]</a:t>
                       </a:r>
                       <a:endParaRPr b="0" lang="en-US" sz="900" spc="-1" strike="noStrike">
                         <a:solidFill>
@@ -53185,7 +53185,7 @@
                           </a:solidFill>
                           <a:latin typeface="Arial"/>
                         </a:rPr>
-                        <a:t>~50 000+</a:t>
+                        <a:t>[клиенты]</a:t>
                       </a:r>
                       <a:endParaRPr b="0" lang="en-US" sz="900" spc="-1" strike="noStrike">
                         <a:solidFill>
@@ -53243,7 +53243,7 @@
                           </a:solidFill>
                           <a:latin typeface="Arial"/>
                         </a:rPr>
-                        <a:t>~5B ₽</a:t>
+                        <a:t>[выручка]</a:t>
                       </a:r>
                       <a:endParaRPr b="0" lang="en-US" sz="900" spc="-1" strike="noStrike">
                         <a:solidFill>
@@ -53301,7 +53301,7 @@
                           </a:solidFill>
                           <a:latin typeface="Arial"/>
                         </a:rPr>
-                        <a:t>Дистрибуция 1 500+ магазинов</a:t>
+                        <a:t>[ключевые фичи]</a:t>
                       </a:r>
                       <a:endParaRPr b="0" lang="en-US" sz="900" spc="-1" strike="noStrike">
                         <a:solidFill>
@@ -53359,7 +53359,7 @@
                           </a:solidFill>
                           <a:latin typeface="Arial"/>
                         </a:rPr>
-                        <a:t>Мелкие камни; масс-сегмент</a:t>
+                        <a:t>[слабость]</a:t>
                       </a:r>
                       <a:endParaRPr b="0" lang="en-US" sz="900" spc="-1" strike="noStrike">
                         <a:solidFill>
@@ -53419,7 +53419,7 @@
                           </a:solidFill>
                           <a:latin typeface="Arial"/>
                         </a:rPr>
-                        <a:t>Wonder Diamond</a:t>
+                        <a:t>[Наш продукт]</a:t>
                       </a:r>
                       <a:endParaRPr b="0" lang="en-US" sz="900" spc="-1" strike="noStrike">
                         <a:solidFill>
@@ -53477,7 +53477,7 @@
                           </a:solidFill>
                           <a:latin typeface="Arial"/>
                         </a:rPr>
-                        <a:t>Онлайн РФ</a:t>
+                        <a:t>[рынок / гео]</a:t>
                       </a:r>
                       <a:endParaRPr b="0" lang="en-US" sz="900" spc="-1" strike="noStrike">
                         <a:solidFill>
@@ -53535,7 +53535,7 @@
                           </a:solidFill>
                           <a:latin typeface="Arial"/>
                         </a:rPr>
-                        <a:t>150K–350K ₽</a:t>
+                        <a:t>[цена]</a:t>
                       </a:r>
                       <a:endParaRPr b="0" lang="en-US" sz="900" spc="-1" strike="noStrike">
                         <a:solidFill>
@@ -53593,7 +53593,7 @@
                           </a:solidFill>
                           <a:latin typeface="Arial"/>
                         </a:rPr>
-                        <a:t>0 (MVP)</a:t>
+                        <a:t>[клиенты]</a:t>
                       </a:r>
                       <a:endParaRPr b="0" lang="en-US" sz="900" spc="-1" strike="noStrike">
                         <a:solidFill>
@@ -53651,7 +53651,7 @@
                           </a:solidFill>
                           <a:latin typeface="Arial"/>
                         </a:rPr>
-                        <a:t>0 (старт)</a:t>
+                        <a:t>[выручка]</a:t>
                       </a:r>
                       <a:endParaRPr b="0" lang="en-US" sz="900" spc="-1" strike="noStrike">
                         <a:solidFill>
@@ -53709,7 +53709,7 @@
                           </a:solidFill>
                           <a:latin typeface="Arial"/>
                         </a:rPr>
-                        <a:t>CVD 6ct+ от производителя, IGI</a:t>
+                        <a:t>[ключевые фичи]</a:t>
                       </a:r>
                       <a:endParaRPr b="0" lang="en-US" sz="900" spc="-1" strike="noStrike">
                         <a:solidFill>
@@ -53767,7 +53767,7 @@
                           </a:solidFill>
                           <a:latin typeface="Arial"/>
                         </a:rPr>
-                        <a:t>Нет клиентов, нет шоурума</a:t>
+                        <a:t>[слабость]</a:t>
                       </a:r>
                       <a:endParaRPr b="0" lang="en-US" sz="900" spc="-1" strike="noStrike">
                         <a:solidFill>
@@ -53997,7 +53997,7 @@
                 <a:latin typeface="Calibri"/>
                 <a:ea typeface="Calibri"/>
               </a:rPr>
-              <a:t>Ключевой конкурент: IQ Diamonds</a:t>
+              <a:t>Ключевой конкурент: [название]</a:t>
             </a:r>
             <a:endParaRPr b="0" lang="en-US" sz="1700" spc="-1" strike="noStrike">
               <a:solidFill>
@@ -54160,7 +54160,7 @@
                 <a:latin typeface="Calibri"/>
                 <a:ea typeface="Calibri"/>
               </a:rPr>
-              <a:t>Источник: iqdiamonds.ru, отзывы ВК/Telegram; аналитика WD 2026</a:t>
+              <a:t>Источник: [сайт конкурента, отзывы, аналитика — задача 4]</a:t>
             </a:r>
             <a:endParaRPr b="0" lang="en-US" sz="800" spc="-1" strike="noStrike">
               <a:solidFill>
@@ -54429,7 +54429,7 @@
                 <a:latin typeface="Calibri"/>
                 <a:ea typeface="Calibri"/>
               </a:rPr>
-              <a:t>Acquisition: SEO «лабораторные бриллианты» (~40%), Instagram/ВК (~25%), прямой трафик (~20%), Telegram (~10%), сарафан (~5%). Оценочный CPC: 80–150 ₽</a:t>
+              <a:t>Acquisition: [каналы с долями трафика]. Оценочный CAC / CPC: [значение]</a:t>
             </a:r>
             <a:endParaRPr b="0" lang="en-US" sz="1000" spc="-1" strike="noStrike">
               <a:solidFill>
@@ -54641,7 +54641,7 @@
                 <a:latin typeface="Calibri"/>
                 <a:ea typeface="Calibri"/>
               </a:rPr>
-              <a:t>Activation: самостоятельный онлайн-каталог с фильтрами (4C, размер, цена). Aha-moment: момент сравнения CVD с натуральным аналогом. Время до first value: ~5 минут</a:t>
+              <a:t>Activation: [механика онбординга]. Aha-moment: [момент]. Время до first value: [значение]</a:t>
             </a:r>
             <a:endParaRPr b="0" lang="en-US" sz="1000" spc="-1" strike="noStrike">
               <a:solidFill>
@@ -54853,7 +54853,7 @@
                 <a:latin typeface="Calibri"/>
                 <a:ea typeface="Calibri"/>
               </a:rPr>
-              <a:t>Retention: нет публичной loyalty-программы. Повторная покупка через контент (посты, истории клиентов). Оценочный repeat rate: ~10% за 12 мес.</a:t>
+              <a:t>Retention: [механизмы удержания]. Оценочный retention / repeat rate: [значение]</a:t>
             </a:r>
             <a:endParaRPr b="0" lang="en-US" sz="1000" spc="-1" strike="noStrike">
               <a:solidFill>
@@ -55065,7 +55065,7 @@
                 <a:latin typeface="Calibri"/>
                 <a:ea typeface="Calibri"/>
               </a:rPr>
-              <a:t>Revenue: разовые продажи украшений 20K–200K ₽. Средний чек: ~60K ₽. Оценочная выручка: ~200 млн ₽/год</a:t>
+              <a:t>Revenue: [модель монетизации]. Средний чек: [значение]. Оценочная выручка: [значение]</a:t>
             </a:r>
             <a:endParaRPr b="0" lang="en-US" sz="1000" spc="-1" strike="noStrike">
               <a:solidFill>
@@ -55277,7 +55277,7 @@
                 <a:latin typeface="Calibri"/>
                 <a:ea typeface="Calibri"/>
               </a:rPr>
-              <a:t>Referral: отзывы на сайте/Wildberries. Нет публичной реферальной программы. NPS не раскрывается. Слабость: нет камней &gt;3ct</a:t>
+              <a:t>Referral: [программы и механики]. NPS: [значение или «не раскрывается»]. Слабость: [ключевая уязвимость]</a:t>
             </a:r>
             <a:endParaRPr b="0" lang="en-US" sz="1000" spc="-1" strike="noStrike">
               <a:solidFill>

</xml_diff>